<commit_message>
Use approved Chen ER diagram in report+presentation; expand report to detailed 4 pages; drop box-style ER
</commit_message>
<xml_diff>
--- a/VIEWFLIX_Presentation.pptx
+++ b/VIEWFLIX_Presentation.pptx
@@ -10720,14 +10720,14 @@
                   <a:srgbClr val="1F3864"/>
                 </a:solidFill>
               </a:rPr>
-              <a:t>ER Diagram - VIEWFLIX</a:t>
+              <a:t>ER Diagram (Chen Notation)</a:t>
             </a:r>
           </a:p>
         </p:txBody>
       </p:sp>
       <p:pic>
         <p:nvPicPr>
-          <p:cNvPr id="6" name="Picture 5" descr="er_viewflix.png"/>
+          <p:cNvPr id="6" name="Picture 5" descr="er_diagram.png"/>
           <p:cNvPicPr>
             <a:picLocks noChangeAspect="1"/>
           </p:cNvPicPr>
@@ -10741,8 +10741,8 @@
         </p:blipFill>
         <p:spPr>
           <a:xfrm>
-            <a:off x="335280" y="1143000"/>
-            <a:ext cx="11521440" cy="4388215"/>
+            <a:off x="4023360" y="1097280"/>
+            <a:ext cx="4260389" cy="5486400"/>
           </a:xfrm>
           <a:prstGeom prst="rect">
             <a:avLst/>

</xml_diff>

<commit_message>
Tighter higher-res ER diagram with clearer cardinalities; expand report to full 4 pages; update presentation
</commit_message>
<xml_diff>
--- a/VIEWFLIX_Presentation.pptx
+++ b/VIEWFLIX_Presentation.pptx
@@ -10741,8 +10741,8 @@
         </p:blipFill>
         <p:spPr>
           <a:xfrm>
-            <a:off x="4023360" y="1097280"/>
-            <a:ext cx="4260389" cy="5486400"/>
+            <a:off x="3931920" y="1051560"/>
+            <a:ext cx="5050871" cy="5532120"/>
           </a:xfrm>
           <a:prstGeom prst="rect">
             <a:avLst/>

</xml_diff>